<commit_message>
Supplier deck: add screenshots for dashboard, prices, orders by branch and messages
Co-Authored-By: Claude Opus 5.5 <noreply@anthropic.com>
Claude-Session: https://claude.ai/code/session_01LHLFw2GTW6okWXxcJBSwir
</commit_message>
<xml_diff>
--- a/presentation/SPAR_Supplier_Training_Deck.pptx
+++ b/presentation/SPAR_Supplier_Training_Deck.pptx
@@ -123,7 +123,7 @@
   <p:extLst>
     <p:ext uri="{521415D9-36F7-43E2-AB2F-B90AF26B5E84}">
       <p14:sectionLst xmlns:p14="http://schemas.microsoft.com/office/powerpoint/2010/main">
-        <p14:section name="Welcome" id="{4d81c678-7201-9a45-55ca-ea807ca5497b}">
+        <p14:section name="Welcome" id="{e967bff7-fbe7-5438-8166-9a4fad3b5373}">
           <p14:sldIdLst>
             <p14:sldId id="256"/>
             <p14:sldId id="257"/>
@@ -131,12 +131,12 @@
             <p14:sldId id="259"/>
           </p14:sldIdLst>
         </p14:section>
-        <p14:section name="Your Role" id="{a4f3b9f6-a95d-27ff-02d5-8dc700d7bb82}">
+        <p14:section name="Your Role" id="{d57bc9c4-0b48-b225-27ef-cd9e1ad6c19c}">
           <p14:sldIdLst>
             <p14:sldId id="260"/>
           </p14:sldIdLst>
         </p14:section>
-        <p14:section name="Key Features" id="{9b3bd63b-45e4-f6c8-aff1-9dca803462ce}">
+        <p14:section name="Key Features" id="{1f85e584-5e6c-a6c1-9117-b3ef0d7e7ab4}">
           <p14:sldIdLst>
             <p14:sldId id="261"/>
             <p14:sldId id="262"/>
@@ -147,7 +147,7 @@
             <p14:sldId id="267"/>
           </p14:sldIdLst>
         </p14:section>
-        <p14:section name="Wrap-up" id="{8fee2feb-5821-8a7c-d3c4-d3a61bff00a9}">
+        <p14:section name="Wrap-up" id="{8a3e1888-7145-1bae-1732-8203c8d9732c}">
           <p14:sldIdLst>
             <p14:sldId id="268"/>
             <p14:sldId id="269"/>
@@ -4194,38 +4194,9 @@
           </a:p>
         </p:txBody>
       </p:sp>
-      <p:sp>
-        <p:nvSpPr>
-          <p:cNvPr id="19" name="Screenshot placeholder"/>
-          <p:cNvSpPr/>
-          <p:nvPr/>
-        </p:nvSpPr>
-        <p:spPr>
-          <a:xfrm>
-            <a:off x="6153912" y="1463040"/>
-            <a:ext cx="5486400" cy="3794760"/>
-          </a:xfrm>
-          <a:prstGeom prst="roundRect">
-            <a:avLst>
-              <a:gd name="adj" fmla="val 2892"/>
-            </a:avLst>
-          </a:prstGeom>
-          <a:solidFill>
-            <a:schemeClr val="tx2">
-              <a:alpha val="65000"/>
-            </a:schemeClr>
-          </a:solidFill>
-          <a:ln w="15875">
-            <a:solidFill>
-              <a:schemeClr val="accent1"/>
-            </a:solidFill>
-            <a:prstDash val="dash"/>
-          </a:ln>
-        </p:spPr>
-      </p:sp>
       <p:pic>
         <p:nvPicPr>
-          <p:cNvPr id="20" name="Screenshot icon" descr="preencoded.png">    </p:cNvPr>
+          <p:cNvPr id="19" name="Screenshot: Messages with Admin" descr="Messages with Admin">    </p:cNvPr>
           <p:cNvPicPr>
             <a:picLocks noChangeAspect="1"/>
           </p:cNvPicPr>
@@ -4239,8 +4210,8 @@
         </p:blipFill>
         <p:spPr>
           <a:xfrm>
-            <a:off x="8622792" y="2720340"/>
-            <a:ext cx="548640" cy="548640"/>
+            <a:off x="6153912" y="1874520"/>
+            <a:ext cx="5486400" cy="3108960"/>
           </a:xfrm>
           <a:prstGeom prst="rect">
             <a:avLst/>
@@ -4249,63 +4220,29 @@
       </p:pic>
       <p:sp>
         <p:nvSpPr>
-          <p:cNvPr id="21" name="Screenshot label"/>
-          <p:cNvSpPr txBox="1"/>
-          <p:nvPr/>
-        </p:nvSpPr>
-        <p:spPr>
-          <a:xfrm>
-            <a:off x="6428232" y="3406140"/>
-            <a:ext cx="4937760" cy="822960"/>
-          </a:xfrm>
-          <a:prstGeom prst="rect">
-            <a:avLst/>
-          </a:prstGeom>
-          <a:noFill/>
-          <a:ln/>
-        </p:spPr>
-        <p:txBody>
-          <a:bodyPr wrap="square" lIns="0" tIns="0" rIns="0" bIns="0" rtlCol="0" anchor="t"/>
-          <a:lstStyle/>
-          <a:p>
-            <a:pPr algn="ctr" indent="0" marL="0">
-              <a:spcAft>
-                <a:spcPts val="400"/>
-              </a:spcAft>
-              <a:buNone/>
-            </a:pPr>
-            <a:r>
-              <a:rPr lang="en-US" sz="1300" b="1" dirty="0">
-                <a:solidFill>
-                  <a:schemeClr val="bg2"/>
-                </a:solidFill>
-              </a:rPr>
-              <a:t>Insert screenshot</a:t>
-            </a:r>
-            <a:endParaRPr lang="en-US" sz="1300" dirty="0"/>
-          </a:p>
-          <a:p>
-            <a:pPr algn="ctr" indent="0" marL="0">
-              <a:spcAft>
-                <a:spcPts val="400"/>
-              </a:spcAft>
-              <a:buNone/>
-            </a:pPr>
-            <a:r>
-              <a:rPr lang="en-US" sz="1300" dirty="0">
-                <a:solidFill>
-                  <a:schemeClr val="bg2"/>
-                </a:solidFill>
-              </a:rPr>
-              <a:t>Account details and Messages screens</a:t>
-            </a:r>
-            <a:endParaRPr lang="en-US" sz="1300" dirty="0"/>
-          </a:p>
-        </p:txBody>
-      </p:sp>
-      <p:sp>
-        <p:nvSpPr>
-          <p:cNvPr id="22" name="Benefit pill"/>
+          <p:cNvPr id="20" name="Screenshot frame"/>
+          <p:cNvSpPr/>
+          <p:nvPr/>
+        </p:nvSpPr>
+        <p:spPr>
+          <a:xfrm>
+            <a:off x="6153912" y="1874520"/>
+            <a:ext cx="5486400" cy="3108960"/>
+          </a:xfrm>
+          <a:prstGeom prst="rect">
+            <a:avLst/>
+          </a:prstGeom>
+          <a:ln w="19050">
+            <a:solidFill>
+              <a:schemeClr val="accent1"/>
+            </a:solidFill>
+            <a:prstDash val="solid"/>
+          </a:ln>
+        </p:spPr>
+      </p:sp>
+      <p:sp>
+        <p:nvSpPr>
+          <p:cNvPr id="21" name="Benefit pill"/>
           <p:cNvSpPr/>
           <p:nvPr/>
         </p:nvSpPr>
@@ -4334,7 +4271,7 @@
       </p:sp>
       <p:pic>
         <p:nvPicPr>
-          <p:cNvPr id="23" name="Benefit icon" descr="preencoded.png">    </p:cNvPr>
+          <p:cNvPr id="22" name="Benefit icon" descr="preencoded.png">    </p:cNvPr>
           <p:cNvPicPr>
             <a:picLocks noChangeAspect="1"/>
           </p:cNvPicPr>
@@ -4358,7 +4295,7 @@
       </p:pic>
       <p:sp>
         <p:nvSpPr>
-          <p:cNvPr id="24" name="Text 15"/>
+          <p:cNvPr id="23" name="Text 14"/>
           <p:cNvSpPr txBox="1"/>
           <p:nvPr/>
         </p:nvSpPr>
@@ -6023,7 +5960,7 @@
                   <a:schemeClr val="bg1"/>
                 </a:solidFill>
               </a:rPr>
-              <a:t>Last prices pre-filled</a:t>
+              <a:t>Last price shown</a:t>
             </a:r>
             <a:endParaRPr lang="en-US" sz="1500" dirty="0"/>
           </a:p>
@@ -6040,7 +5977,7 @@
                   <a:schemeClr val="bg2"/>
                 </a:solidFill>
               </a:rPr>
-              <a:t>Only change what moved</a:t>
+              <a:t>A guide for every item</a:t>
             </a:r>
             <a:endParaRPr lang="en-US" sz="1500" dirty="0"/>
           </a:p>
@@ -13446,38 +13383,9 @@
           </a:p>
         </p:txBody>
       </p:sp>
-      <p:sp>
-        <p:nvSpPr>
-          <p:cNvPr id="40" name="Screenshot placeholder"/>
-          <p:cNvSpPr/>
-          <p:nvPr/>
-        </p:nvSpPr>
-        <p:spPr>
-          <a:xfrm>
-            <a:off x="7406640" y="1783080"/>
-            <a:ext cx="4233672" cy="3529584"/>
-          </a:xfrm>
-          <a:prstGeom prst="roundRect">
-            <a:avLst>
-              <a:gd name="adj" fmla="val 3109"/>
-            </a:avLst>
-          </a:prstGeom>
-          <a:solidFill>
-            <a:schemeClr val="tx2">
-              <a:alpha val="65000"/>
-            </a:schemeClr>
-          </a:solidFill>
-          <a:ln w="15875">
-            <a:solidFill>
-              <a:schemeClr val="accent1"/>
-            </a:solidFill>
-            <a:prstDash val="dash"/>
-          </a:ln>
-        </p:spPr>
-      </p:sp>
       <p:pic>
         <p:nvPicPr>
-          <p:cNvPr id="41" name="Screenshot icon" descr="preencoded.png">    </p:cNvPr>
+          <p:cNvPr id="40" name="Screenshot: Supplier Dashboard with the eight tabs" descr="Supplier Dashboard with the eight tabs">    </p:cNvPr>
           <p:cNvPicPr>
             <a:picLocks noChangeAspect="1"/>
           </p:cNvPicPr>
@@ -13491,8 +13399,8 @@
         </p:blipFill>
         <p:spPr>
           <a:xfrm>
-            <a:off x="9249156" y="2907792"/>
-            <a:ext cx="548640" cy="548640"/>
+            <a:off x="7406640" y="1783080"/>
+            <a:ext cx="4233672" cy="3529584"/>
           </a:xfrm>
           <a:prstGeom prst="rect">
             <a:avLst/>
@@ -13501,63 +13409,29 @@
       </p:pic>
       <p:sp>
         <p:nvSpPr>
-          <p:cNvPr id="42" name="Screenshot label"/>
-          <p:cNvSpPr txBox="1"/>
-          <p:nvPr/>
-        </p:nvSpPr>
-        <p:spPr>
-          <a:xfrm>
-            <a:off x="7680960" y="3593592"/>
-            <a:ext cx="3685032" cy="822960"/>
-          </a:xfrm>
-          <a:prstGeom prst="rect">
-            <a:avLst/>
-          </a:prstGeom>
-          <a:noFill/>
-          <a:ln/>
-        </p:spPr>
-        <p:txBody>
-          <a:bodyPr wrap="square" lIns="0" tIns="0" rIns="0" bIns="0" rtlCol="0" anchor="t"/>
-          <a:lstStyle/>
-          <a:p>
-            <a:pPr algn="ctr" indent="0" marL="0">
-              <a:spcAft>
-                <a:spcPts val="400"/>
-              </a:spcAft>
-              <a:buNone/>
-            </a:pPr>
-            <a:r>
-              <a:rPr lang="en-US" sz="1300" b="1" dirty="0">
-                <a:solidFill>
-                  <a:schemeClr val="bg2"/>
-                </a:solidFill>
-              </a:rPr>
-              <a:t>Insert screenshot</a:t>
-            </a:r>
-            <a:endParaRPr lang="en-US" sz="1300" dirty="0"/>
-          </a:p>
-          <a:p>
-            <a:pPr algn="ctr" indent="0" marL="0">
-              <a:spcAft>
-                <a:spcPts val="400"/>
-              </a:spcAft>
-              <a:buNone/>
-            </a:pPr>
-            <a:r>
-              <a:rPr lang="en-US" sz="1300" dirty="0">
-                <a:solidFill>
-                  <a:schemeClr val="bg2"/>
-                </a:solidFill>
-              </a:rPr>
-              <a:t>Supplier Dashboard with the eight tabs</a:t>
-            </a:r>
-            <a:endParaRPr lang="en-US" sz="1300" dirty="0"/>
-          </a:p>
-        </p:txBody>
-      </p:sp>
-      <p:sp>
-        <p:nvSpPr>
-          <p:cNvPr id="43" name="Benefit pill"/>
+          <p:cNvPr id="41" name="Screenshot frame"/>
+          <p:cNvSpPr/>
+          <p:nvPr/>
+        </p:nvSpPr>
+        <p:spPr>
+          <a:xfrm>
+            <a:off x="7406640" y="1783080"/>
+            <a:ext cx="4233672" cy="3529584"/>
+          </a:xfrm>
+          <a:prstGeom prst="rect">
+            <a:avLst/>
+          </a:prstGeom>
+          <a:ln w="19050">
+            <a:solidFill>
+              <a:schemeClr val="accent1"/>
+            </a:solidFill>
+            <a:prstDash val="solid"/>
+          </a:ln>
+        </p:spPr>
+      </p:sp>
+      <p:sp>
+        <p:nvSpPr>
+          <p:cNvPr id="42" name="Benefit pill"/>
           <p:cNvSpPr/>
           <p:nvPr/>
         </p:nvSpPr>
@@ -13586,7 +13460,7 @@
       </p:sp>
       <p:pic>
         <p:nvPicPr>
-          <p:cNvPr id="44" name="Benefit icon" descr="preencoded.png">    </p:cNvPr>
+          <p:cNvPr id="43" name="Benefit icon" descr="preencoded.png">    </p:cNvPr>
           <p:cNvPicPr>
             <a:picLocks noChangeAspect="1"/>
           </p:cNvPicPr>
@@ -13610,7 +13484,7 @@
       </p:pic>
       <p:sp>
         <p:nvSpPr>
-          <p:cNvPr id="45" name="Text 31"/>
+          <p:cNvPr id="44" name="Text 30"/>
           <p:cNvSpPr txBox="1"/>
           <p:nvPr/>
         </p:nvSpPr>
@@ -14189,7 +14063,7 @@
                   <a:schemeClr val="bg2"/>
                 </a:solidFill>
               </a:rPr>
-              <a:t>Type a Rs. price for each item you can supply. Your last price is filled in to start.</a:t>
+              <a:t>Type a Rs. price for each item you can supply. Your last price is shown under each item.</a:t>
             </a:r>
             <a:endParaRPr lang="en-US" sz="1500" dirty="0"/>
           </a:p>
@@ -14579,38 +14453,9 @@
           </a:p>
         </p:txBody>
       </p:sp>
-      <p:sp>
-        <p:nvSpPr>
-          <p:cNvPr id="23" name="Screenshot placeholder"/>
-          <p:cNvSpPr/>
-          <p:nvPr/>
-        </p:nvSpPr>
-        <p:spPr>
-          <a:xfrm>
-            <a:off x="6812280" y="3840480"/>
-            <a:ext cx="4828032" cy="1554480"/>
-          </a:xfrm>
-          <a:prstGeom prst="roundRect">
-            <a:avLst>
-              <a:gd name="adj" fmla="val 7059"/>
-            </a:avLst>
-          </a:prstGeom>
-          <a:solidFill>
-            <a:schemeClr val="tx2">
-              <a:alpha val="65000"/>
-            </a:schemeClr>
-          </a:solidFill>
-          <a:ln w="15875">
-            <a:solidFill>
-              <a:schemeClr val="accent1"/>
-            </a:solidFill>
-            <a:prstDash val="dash"/>
-          </a:ln>
-        </p:spPr>
-      </p:sp>
       <p:pic>
         <p:nvPicPr>
-          <p:cNvPr id="24" name="Screenshot icon" descr="preencoded.png">    </p:cNvPr>
+          <p:cNvPr id="23" name="Screenshot: Submit Prices form: last price shown, photo on hover" descr="Submit Prices form: last price shown, photo on hover">    </p:cNvPr>
           <p:cNvPicPr>
             <a:picLocks noChangeAspect="1"/>
           </p:cNvPicPr>
@@ -14624,8 +14469,8 @@
         </p:blipFill>
         <p:spPr>
           <a:xfrm>
-            <a:off x="8951976" y="3977640"/>
-            <a:ext cx="548640" cy="548640"/>
+            <a:off x="6812280" y="3840480"/>
+            <a:ext cx="4828032" cy="1554480"/>
           </a:xfrm>
           <a:prstGeom prst="rect">
             <a:avLst/>
@@ -14634,63 +14479,29 @@
       </p:pic>
       <p:sp>
         <p:nvSpPr>
-          <p:cNvPr id="25" name="Screenshot label"/>
-          <p:cNvSpPr txBox="1"/>
-          <p:nvPr/>
-        </p:nvSpPr>
-        <p:spPr>
-          <a:xfrm>
-            <a:off x="7086600" y="4663440"/>
-            <a:ext cx="4279392" cy="822960"/>
-          </a:xfrm>
-          <a:prstGeom prst="rect">
-            <a:avLst/>
-          </a:prstGeom>
-          <a:noFill/>
-          <a:ln/>
-        </p:spPr>
-        <p:txBody>
-          <a:bodyPr wrap="square" lIns="0" tIns="0" rIns="0" bIns="0" rtlCol="0" anchor="t"/>
-          <a:lstStyle/>
-          <a:p>
-            <a:pPr algn="ctr" indent="0" marL="0">
-              <a:spcAft>
-                <a:spcPts val="400"/>
-              </a:spcAft>
-              <a:buNone/>
-            </a:pPr>
-            <a:r>
-              <a:rPr lang="en-US" sz="1300" b="1" dirty="0">
-                <a:solidFill>
-                  <a:schemeClr val="bg2"/>
-                </a:solidFill>
-              </a:rPr>
-              <a:t>Insert screenshot</a:t>
-            </a:r>
-            <a:endParaRPr lang="en-US" sz="1300" dirty="0"/>
-          </a:p>
-          <a:p>
-            <a:pPr algn="ctr" indent="0" marL="0">
-              <a:spcAft>
-                <a:spcPts val="400"/>
-              </a:spcAft>
-              <a:buNone/>
-            </a:pPr>
-            <a:r>
-              <a:rPr lang="en-US" sz="1300" dirty="0">
-                <a:solidFill>
-                  <a:schemeClr val="bg2"/>
-                </a:solidFill>
-              </a:rPr>
-              <a:t>Submit Prices form with prices entered</a:t>
-            </a:r>
-            <a:endParaRPr lang="en-US" sz="1300" dirty="0"/>
-          </a:p>
-        </p:txBody>
-      </p:sp>
-      <p:sp>
-        <p:nvSpPr>
-          <p:cNvPr id="26" name="Benefit pill"/>
+          <p:cNvPr id="24" name="Screenshot frame"/>
+          <p:cNvSpPr/>
+          <p:nvPr/>
+        </p:nvSpPr>
+        <p:spPr>
+          <a:xfrm>
+            <a:off x="6812280" y="3840480"/>
+            <a:ext cx="4828032" cy="1554480"/>
+          </a:xfrm>
+          <a:prstGeom prst="rect">
+            <a:avLst/>
+          </a:prstGeom>
+          <a:ln w="19050">
+            <a:solidFill>
+              <a:schemeClr val="accent1"/>
+            </a:solidFill>
+            <a:prstDash val="solid"/>
+          </a:ln>
+        </p:spPr>
+      </p:sp>
+      <p:sp>
+        <p:nvSpPr>
+          <p:cNvPr id="25" name="Benefit pill"/>
           <p:cNvSpPr/>
           <p:nvPr/>
         </p:nvSpPr>
@@ -14719,7 +14530,7 @@
       </p:sp>
       <p:pic>
         <p:nvPicPr>
-          <p:cNvPr id="27" name="Benefit icon" descr="preencoded.png">    </p:cNvPr>
+          <p:cNvPr id="26" name="Benefit icon" descr="preencoded.png">    </p:cNvPr>
           <p:cNvPicPr>
             <a:picLocks noChangeAspect="1"/>
           </p:cNvPicPr>
@@ -14743,7 +14554,7 @@
       </p:pic>
       <p:sp>
         <p:nvSpPr>
-          <p:cNvPr id="28" name="Text 21"/>
+          <p:cNvPr id="27" name="Text 20"/>
           <p:cNvSpPr txBox="1"/>
           <p:nvPr/>
         </p:nvSpPr>
@@ -14788,7 +14599,7 @@
                   <a:schemeClr val="bg1"/>
                 </a:solidFill>
               </a:rPr>
-              <a:t>Quick to fill in, pre-filled with your last prices, and easy to correct before the cutoff.</a:t>
+              <a:t>Quick to fill in, your last price as a guide, and easy to correct before the cutoff.</a:t>
             </a:r>
             <a:endParaRPr lang="en-US" sz="1600" dirty="0"/>
           </a:p>
@@ -16643,38 +16454,9 @@
           </a:p>
         </p:txBody>
       </p:sp>
-      <p:sp>
-        <p:nvSpPr>
-          <p:cNvPr id="20" name="Screenshot placeholder"/>
-          <p:cNvSpPr/>
-          <p:nvPr/>
-        </p:nvSpPr>
-        <p:spPr>
-          <a:xfrm>
-            <a:off x="6153912" y="1417320"/>
-            <a:ext cx="5486400" cy="3977640"/>
-          </a:xfrm>
-          <a:prstGeom prst="roundRect">
-            <a:avLst>
-              <a:gd name="adj" fmla="val 2759"/>
-            </a:avLst>
-          </a:prstGeom>
-          <a:solidFill>
-            <a:schemeClr val="tx2">
-              <a:alpha val="65000"/>
-            </a:schemeClr>
-          </a:solidFill>
-          <a:ln w="15875">
-            <a:solidFill>
-              <a:schemeClr val="accent1"/>
-            </a:solidFill>
-            <a:prstDash val="dash"/>
-          </a:ln>
-        </p:spPr>
-      </p:sp>
       <p:pic>
         <p:nvPicPr>
-          <p:cNvPr id="21" name="Screenshot icon" descr="preencoded.png">    </p:cNvPr>
+          <p:cNvPr id="20" name="Screenshot: Orders by Branch table for one delivery date" descr="Orders by Branch table for one delivery date">    </p:cNvPr>
           <p:cNvPicPr>
             <a:picLocks noChangeAspect="1"/>
           </p:cNvPicPr>
@@ -16688,8 +16470,8 @@
         </p:blipFill>
         <p:spPr>
           <a:xfrm>
-            <a:off x="8622792" y="2766060"/>
-            <a:ext cx="548640" cy="548640"/>
+            <a:off x="6153912" y="1417320"/>
+            <a:ext cx="5486400" cy="2176272"/>
           </a:xfrm>
           <a:prstGeom prst="rect">
             <a:avLst/>
@@ -16698,14 +16480,65 @@
       </p:pic>
       <p:sp>
         <p:nvSpPr>
-          <p:cNvPr id="22" name="Screenshot label"/>
+          <p:cNvPr id="21" name="Screenshot frame"/>
+          <p:cNvSpPr/>
+          <p:nvPr/>
+        </p:nvSpPr>
+        <p:spPr>
+          <a:xfrm>
+            <a:off x="6153912" y="1417320"/>
+            <a:ext cx="5486400" cy="2176272"/>
+          </a:xfrm>
+          <a:prstGeom prst="rect">
+            <a:avLst/>
+          </a:prstGeom>
+          <a:ln w="19050">
+            <a:solidFill>
+              <a:schemeClr val="accent1"/>
+            </a:solidFill>
+            <a:prstDash val="solid"/>
+          </a:ln>
+        </p:spPr>
+      </p:sp>
+      <p:sp>
+        <p:nvSpPr>
+          <p:cNvPr id="22" name="Orders reading card"/>
+          <p:cNvSpPr/>
+          <p:nvPr/>
+        </p:nvSpPr>
+        <p:spPr>
+          <a:xfrm>
+            <a:off x="6153912" y="3794760"/>
+            <a:ext cx="5486400" cy="1600200"/>
+          </a:xfrm>
+          <a:prstGeom prst="roundRect">
+            <a:avLst>
+              <a:gd name="adj" fmla="val 6857"/>
+            </a:avLst>
+          </a:prstGeom>
+          <a:solidFill>
+            <a:schemeClr val="accent6">
+              <a:alpha val="88000"/>
+            </a:schemeClr>
+          </a:solidFill>
+          <a:ln w="12700">
+            <a:solidFill>
+              <a:schemeClr val="accent5"/>
+            </a:solidFill>
+            <a:prstDash val="solid"/>
+          </a:ln>
+        </p:spPr>
+      </p:sp>
+      <p:sp>
+        <p:nvSpPr>
+          <p:cNvPr id="23" name="Text 14"/>
           <p:cNvSpPr txBox="1"/>
           <p:nvPr/>
         </p:nvSpPr>
         <p:spPr>
           <a:xfrm>
-            <a:off x="6428232" y="3451860"/>
-            <a:ext cx="4937760" cy="822960"/>
+            <a:off x="6428232" y="3794760"/>
+            <a:ext cx="4937760" cy="1600200"/>
           </a:xfrm>
           <a:prstGeom prst="rect">
             <a:avLst/>
@@ -16714,47 +16547,44 @@
           <a:ln/>
         </p:spPr>
         <p:txBody>
-          <a:bodyPr wrap="square" lIns="0" tIns="0" rIns="0" bIns="0" rtlCol="0" anchor="t"/>
+          <a:bodyPr wrap="square" lIns="0" tIns="0" rIns="0" bIns="0" rtlCol="0" anchor="ctr"/>
           <a:lstStyle/>
           <a:p>
-            <a:pPr algn="ctr" indent="0" marL="0">
+            <a:pPr indent="0" marL="0">
               <a:spcAft>
                 <a:spcPts val="400"/>
               </a:spcAft>
               <a:buNone/>
             </a:pPr>
             <a:r>
-              <a:rPr lang="en-US" sz="1300" b="1" dirty="0">
-                <a:solidFill>
-                  <a:schemeClr val="bg2"/>
-                </a:solidFill>
-              </a:rPr>
-              <a:t>Insert screenshot</a:t>
-            </a:r>
-            <a:endParaRPr lang="en-US" sz="1300" dirty="0"/>
-          </a:p>
-          <a:p>
-            <a:pPr algn="ctr" indent="0" marL="0">
+              <a:rPr lang="en-US" sz="1500" b="1" dirty="0">
+                <a:solidFill>
+                  <a:schemeClr val="accent1"/>
+                </a:solidFill>
+              </a:rPr>
+              <a:t>Reading the table: </a:t>
+            </a:r>
+            <a:pPr indent="0" marL="0">
               <a:spcAft>
                 <a:spcPts val="400"/>
               </a:spcAft>
               <a:buNone/>
             </a:pPr>
             <a:r>
-              <a:rPr lang="en-US" sz="1300" dirty="0">
-                <a:solidFill>
-                  <a:schemeClr val="bg2"/>
-                </a:solidFill>
-              </a:rPr>
-              <a:t>Orders by Branch table for one delivery date</a:t>
-            </a:r>
-            <a:endParaRPr lang="en-US" sz="1300" dirty="0"/>
-          </a:p>
-        </p:txBody>
-      </p:sp>
-      <p:sp>
-        <p:nvSpPr>
-          <p:cNvPr id="23" name="Benefit pill"/>
+              <a:rPr lang="en-US" sz="1500" dirty="0">
+                <a:solidFill>
+                  <a:schemeClr val="bg1"/>
+                </a:solidFill>
+              </a:rPr>
+              <a:t>the top line shows the number of stores, items and the total order value. Highlighted cells show which branch ordered what; the Total column is what you load.</a:t>
+            </a:r>
+            <a:endParaRPr lang="en-US" sz="1500" dirty="0"/>
+          </a:p>
+        </p:txBody>
+      </p:sp>
+      <p:sp>
+        <p:nvSpPr>
+          <p:cNvPr id="24" name="Benefit pill"/>
           <p:cNvSpPr/>
           <p:nvPr/>
         </p:nvSpPr>
@@ -16783,7 +16613,7 @@
       </p:sp>
       <p:pic>
         <p:nvPicPr>
-          <p:cNvPr id="24" name="Benefit icon" descr="preencoded.png">    </p:cNvPr>
+          <p:cNvPr id="25" name="Benefit icon" descr="preencoded.png">    </p:cNvPr>
           <p:cNvPicPr>
             <a:picLocks noChangeAspect="1"/>
           </p:cNvPicPr>
@@ -16807,7 +16637,7 @@
       </p:pic>
       <p:sp>
         <p:nvSpPr>
-          <p:cNvPr id="25" name="Text 15"/>
+          <p:cNvPr id="26" name="Text 16"/>
           <p:cNvSpPr txBox="1"/>
           <p:nvPr/>
         </p:nvSpPr>

</xml_diff>

<commit_message>
Supplier deck: add purchase order screenshot
Co-Authored-By: Claude Opus 5.5 <noreply@anthropic.com>
Claude-Session: https://claude.ai/code/session_01LHLFw2GTW6okWXxcJBSwir
</commit_message>
<xml_diff>
--- a/presentation/SPAR_Supplier_Training_Deck.pptx
+++ b/presentation/SPAR_Supplier_Training_Deck.pptx
@@ -123,7 +123,7 @@
   <p:extLst>
     <p:ext uri="{521415D9-36F7-43E2-AB2F-B90AF26B5E84}">
       <p14:sectionLst xmlns:p14="http://schemas.microsoft.com/office/powerpoint/2010/main">
-        <p14:section name="Welcome" id="{e967bff7-fbe7-5438-8166-9a4fad3b5373}">
+        <p14:section name="Welcome" id="{428639ff-951f-bdfa-ee67-cb646988a82b}">
           <p14:sldIdLst>
             <p14:sldId id="256"/>
             <p14:sldId id="257"/>
@@ -131,12 +131,12 @@
             <p14:sldId id="259"/>
           </p14:sldIdLst>
         </p14:section>
-        <p14:section name="Your Role" id="{d57bc9c4-0b48-b225-27ef-cd9e1ad6c19c}">
+        <p14:section name="Your Role" id="{cf0a0edd-b10b-ad78-7fca-413763346f1f}">
           <p14:sldIdLst>
             <p14:sldId id="260"/>
           </p14:sldIdLst>
         </p14:section>
-        <p14:section name="Key Features" id="{1f85e584-5e6c-a6c1-9117-b3ef0d7e7ab4}">
+        <p14:section name="Key Features" id="{4b8c0541-1ac5-13e1-3e0b-0c24b3df6e13}">
           <p14:sldIdLst>
             <p14:sldId id="261"/>
             <p14:sldId id="262"/>
@@ -147,7 +147,7 @@
             <p14:sldId id="267"/>
           </p14:sldIdLst>
         </p14:section>
-        <p14:section name="Wrap-up" id="{8a3e1888-7145-1bae-1732-8203c8d9732c}">
+        <p14:section name="Wrap-up" id="{e94637c4-9f7f-1bda-b223-45800c834224}">
           <p14:sldIdLst>
             <p14:sldId id="268"/>
             <p14:sldId id="269"/>
@@ -3285,38 +3285,9 @@
           </a:p>
         </p:txBody>
       </p:sp>
-      <p:sp>
-        <p:nvSpPr>
-          <p:cNvPr id="20" name="Screenshot placeholder"/>
-          <p:cNvSpPr/>
-          <p:nvPr/>
-        </p:nvSpPr>
-        <p:spPr>
-          <a:xfrm>
-            <a:off x="6153912" y="1417320"/>
-            <a:ext cx="5486400" cy="3977640"/>
-          </a:xfrm>
-          <a:prstGeom prst="roundRect">
-            <a:avLst>
-              <a:gd name="adj" fmla="val 2759"/>
-            </a:avLst>
-          </a:prstGeom>
-          <a:solidFill>
-            <a:schemeClr val="tx2">
-              <a:alpha val="65000"/>
-            </a:schemeClr>
-          </a:solidFill>
-          <a:ln w="15875">
-            <a:solidFill>
-              <a:schemeClr val="accent1"/>
-            </a:solidFill>
-            <a:prstDash val="dash"/>
-          </a:ln>
-        </p:spPr>
-      </p:sp>
       <p:pic>
         <p:nvPicPr>
-          <p:cNvPr id="21" name="Screenshot icon" descr="preencoded.png">    </p:cNvPr>
+          <p:cNvPr id="20" name="Screenshot: An opened purchase order, approved and e-signed by SPAR" descr="An opened purchase order, approved and e-signed by SPAR">    </p:cNvPr>
           <p:cNvPicPr>
             <a:picLocks noChangeAspect="1"/>
           </p:cNvPicPr>
@@ -3330,8 +3301,8 @@
         </p:blipFill>
         <p:spPr>
           <a:xfrm>
-            <a:off x="8622792" y="2766060"/>
-            <a:ext cx="548640" cy="548640"/>
+            <a:off x="6153912" y="1852574"/>
+            <a:ext cx="5486400" cy="3107131"/>
           </a:xfrm>
           <a:prstGeom prst="rect">
             <a:avLst/>
@@ -3340,63 +3311,29 @@
       </p:pic>
       <p:sp>
         <p:nvSpPr>
-          <p:cNvPr id="22" name="Screenshot label"/>
-          <p:cNvSpPr txBox="1"/>
-          <p:nvPr/>
-        </p:nvSpPr>
-        <p:spPr>
-          <a:xfrm>
-            <a:off x="6428232" y="3451860"/>
-            <a:ext cx="4937760" cy="822960"/>
-          </a:xfrm>
-          <a:prstGeom prst="rect">
-            <a:avLst/>
-          </a:prstGeom>
-          <a:noFill/>
-          <a:ln/>
-        </p:spPr>
-        <p:txBody>
-          <a:bodyPr wrap="square" lIns="0" tIns="0" rIns="0" bIns="0" rtlCol="0" anchor="t"/>
-          <a:lstStyle/>
-          <a:p>
-            <a:pPr algn="ctr" indent="0" marL="0">
-              <a:spcAft>
-                <a:spcPts val="400"/>
-              </a:spcAft>
-              <a:buNone/>
-            </a:pPr>
-            <a:r>
-              <a:rPr lang="en-US" sz="1300" b="1" dirty="0">
-                <a:solidFill>
-                  <a:schemeClr val="bg2"/>
-                </a:solidFill>
-              </a:rPr>
-              <a:t>Insert screenshot</a:t>
-            </a:r>
-            <a:endParaRPr lang="en-US" sz="1300" dirty="0"/>
-          </a:p>
-          <a:p>
-            <a:pPr algn="ctr" indent="0" marL="0">
-              <a:spcAft>
-                <a:spcPts val="400"/>
-              </a:spcAft>
-              <a:buNone/>
-            </a:pPr>
-            <a:r>
-              <a:rPr lang="en-US" sz="1300" dirty="0">
-                <a:solidFill>
-                  <a:schemeClr val="bg2"/>
-                </a:solidFill>
-              </a:rPr>
-              <a:t>An opened purchase order, approved by SPAR</a:t>
-            </a:r>
-            <a:endParaRPr lang="en-US" sz="1300" dirty="0"/>
-          </a:p>
-        </p:txBody>
-      </p:sp>
-      <p:sp>
-        <p:nvSpPr>
-          <p:cNvPr id="23" name="Benefit pill"/>
+          <p:cNvPr id="21" name="Screenshot frame"/>
+          <p:cNvSpPr/>
+          <p:nvPr/>
+        </p:nvSpPr>
+        <p:spPr>
+          <a:xfrm>
+            <a:off x="6153912" y="1852574"/>
+            <a:ext cx="5486400" cy="3107131"/>
+          </a:xfrm>
+          <a:prstGeom prst="rect">
+            <a:avLst/>
+          </a:prstGeom>
+          <a:ln w="19050">
+            <a:solidFill>
+              <a:schemeClr val="accent1"/>
+            </a:solidFill>
+            <a:prstDash val="solid"/>
+          </a:ln>
+        </p:spPr>
+      </p:sp>
+      <p:sp>
+        <p:nvSpPr>
+          <p:cNvPr id="22" name="Benefit pill"/>
           <p:cNvSpPr/>
           <p:nvPr/>
         </p:nvSpPr>
@@ -3425,7 +3362,7 @@
       </p:sp>
       <p:pic>
         <p:nvPicPr>
-          <p:cNvPr id="24" name="Benefit icon" descr="preencoded.png">    </p:cNvPr>
+          <p:cNvPr id="23" name="Benefit icon" descr="preencoded.png">    </p:cNvPr>
           <p:cNvPicPr>
             <a:picLocks noChangeAspect="1"/>
           </p:cNvPicPr>
@@ -3449,7 +3386,7 @@
       </p:pic>
       <p:sp>
         <p:nvSpPr>
-          <p:cNvPr id="25" name="Text 15"/>
+          <p:cNvPr id="24" name="Text 14"/>
           <p:cNvSpPr txBox="1"/>
           <p:nvPr/>
         </p:nvSpPr>

</xml_diff>